<commit_message>
docs(slides): repair and update the master's project deck
Repackage the pptx so PowerPoint can open it (valid content types, no
directory entries). Correct the AI credits wording to per user, update
the ADR count, add decision references and the observability limits to
the speaker notes, and remove local paths from image alt text.
</commit_message>
<xml_diff>
--- a/static/tfm/open-projects-hub-tfm.pptx
+++ b/static/tfm/open-projects-hub-tfm.pptx
@@ -728,7 +728,7 @@
           <a:p>
             <a:r>
               <a:rPr lang="en-US" dirty="0"/>
-              <a:t>Explain AI-assisted development through specs, repository instructions, skills, review, and human responsibility. ADR-019 supplies a concrete documented example of human direction: the initial implementation persisted drafts in story_drafts; the product owner rejected that storage, and the design moved to browser-only drafts with approval as the save boundary. The ADR does not identify who proposed the original implementation, so do not attribute that proposal to an AI or invent a rejected AI conversation.</a:t>
+              <a:t>Explain AI-assisted development through specs, repository instructions, skills, review, and human responsibility. ADR-019 records the resulting decision: refined drafts stay in the browser and approval is the save boundary. The earlier server-side draft storage (story_drafts) is visible in the repository history, where the product owner rejected it. The record does not identify who proposed the original implementation, so do not attribute that proposal to an AI or invent a rejected AI conversation.</a:t>
             </a:r>
             <a:endParaRPr lang="en-US" dirty="0"/>
           </a:p>
@@ -816,7 +816,7 @@
           <a:p>
             <a:r>
               <a:rPr lang="en-US" dirty="0"/>
-              <a:t>Discuss objectives, delivered capabilities, and the exact available evidence. Refinement/approval and client-review tests are source artifacts; this slide does not report a fresh passing run or completed user study. No time-saving, usability or model-quality result has been measured. Remaining risks include a single host without automated backups or failover, origin TLS without certificate validation, shared project access without per-stakeholder audit, advisory API type checking, excluded API integration tests, and web E2E outside CI. Source: docs/00-context/evidence-and-limitations.md.</a:t>
+              <a:t>Discuss objectives, delivered capabilities, and the exact available evidence. Refinement/approval and client-review tests are source artifacts; this slide does not report a fresh passing run or completed user study. No time-saving, usability or model-quality result has been measured. Remaining risks include a single host without automated backups or failover, origin TLS without certificate validation, shared project access without per-stakeholder audit, advisory API type checking, excluded API integration tests, web E2E outside CI, and observability limited to Sentry with no alert rules or uptime check (ADR-009). Source: docs/00-context/evidence-and-limitations.md.</a:t>
             </a:r>
             <a:endParaRPr lang="en-US" dirty="0"/>
           </a:p>
@@ -1344,7 +1344,7 @@
           <a:p>
             <a:r>
               <a:rPr lang="en-US" dirty="0"/>
-              <a:t>Client Review is account-free and read-only. This screenshot uses fictional data and a staged public API response. A shared project access code can be regenerated to revoke the previous code. The client reloads to fetch newly approved stories; this is not a live-push or polling interface.</a:t>
+              <a:t>Client Review is account-free and read-only. This screenshot uses fictional data and a staged public API response. A shared project access code can be regenerated to revoke the previous code. The client reloads to fetch newly approved stories; this is not a live-push or polling interface. Decision: ADR-020 (access code, no viewer accounts).</a:t>
             </a:r>
             <a:endParaRPr lang="en-US" dirty="0"/>
           </a:p>
@@ -1520,7 +1520,7 @@
           <a:p>
             <a:r>
               <a:rPr lang="en-US" dirty="0"/>
-              <a:t>The browser separately fetches static web/docs assets from Workers and calls the API through the Cloudflare API proxy. HTTPS reaches Caddy, then the FastAPI container and PostgreSQL on one EC2 host in us-east-2. AI and email are runtime services. GitHub Actions only publishes the GHCR image. An engineer runs deploy-release.sh with AWS credentials, invoking SSM Run Command; host deployment reads SSM parameters and pulls the tagged image. Terraform is applied locally. Cloudflare Full encrypts the origin leg without validating the origin certificate; no automated database backups or failover exist.</a:t>
+              <a:t>The browser separately fetches static web/docs assets from Workers and calls the API through the Cloudflare API proxy. HTTPS reaches Caddy, then the FastAPI container and PostgreSQL on one EC2 host in us-east-2. AI and email are runtime services (email through Resend, ADR-024). Sentry in the API and the web app is the only observability tool; no alert rules or uptime probe are configured (ADR-009). Decisions: ADR-021 single host, ADR-022 Cloudflare edge, ADR-023 account, region and manual deploys. GitHub Actions only publishes the GHCR image. An engineer runs deploy-release.sh with AWS credentials, invoking SSM Run Command; host deployment reads SSM parameters and pulls the tagged image. Terraform is applied locally. Cloudflare Full encrypts the origin leg without validating the origin certificate; no automated database backups or failover exist.</a:t>
             </a:r>
             <a:endParaRPr lang="en-US" dirty="0"/>
           </a:p>
@@ -1608,7 +1608,7 @@
           <a:p>
             <a:r>
               <a:rPr lang="en-US" dirty="0"/>
-              <a:t>Providers are adapters behind a port. Personal keys are encrypted at rest. Unapproved drafts are stored in browser session storage so they survive reloads within the tab, but are not persisted server-side. Closing the tab loses them. Structured output parsing and sanitization reduce specific risks; they do not guarantee model accuracy or comprehensive prompt-injection resistance.</a:t>
+              <a:t>Providers are adapters behind a port. Each user gets 5 free platform credits and a workspace is capped at 25. Personal keys are encrypted at rest (ADR-018). Unapproved drafts are stored in browser session storage so they survive reloads within the tab, but are not persisted server-side. Closing the tab loses them. Structured output parsing and sanitization reduce specific risks; they do not guarantee model accuracy or comprehensive prompt-injection resistance.</a:t>
             </a:r>
             <a:endParaRPr lang="en-US" dirty="0"/>
           </a:p>
@@ -2232,7 +2232,7 @@
       </p:sp>
       <p:pic>
         <p:nvPicPr>
-          <p:cNvPr id="3" name="Image 0" descr="/private/tmp/claude-501/-Users-alonso-Documents-Workspace-Alonsovndev-OpenProjectsHub/19cdd931-d4c3-4bf1-911a-d568f533b6da/scratchpad/deck/app-logo.png">    </p:cNvPr>
+          <p:cNvPr id="3" name="Image 0" descr="Open Projects Hub logo">    </p:cNvPr>
           <p:cNvPicPr>
             <a:picLocks noChangeAspect="1"/>
           </p:cNvPicPr>
@@ -2436,7 +2436,7 @@
       </p:sp>
       <p:pic>
         <p:nvPicPr>
-          <p:cNvPr id="8" name="Image 1" descr="/Users/alonso/Documents/Workspace/Alonsovndev/OpenProjectsHub/open-projects-hub-docs/static/img/product/refinement-workspace.png">    </p:cNvPr>
+          <p:cNvPr id="8" name="Image 1" descr="Refinement workspace screenshot (illustrative UI, fictional data)">    </p:cNvPr>
           <p:cNvPicPr>
             <a:picLocks noChangeAspect="1"/>
           </p:cNvPicPr>
@@ -3739,7 +3739,7 @@
                   <a:schemeClr val="accent6"/>
                 </a:solidFill>
               </a:rPr>
-              <a:t>24 ADRs keep the reasoning behind each choice available to people and agents.</a:t>
+              <a:t>23 ADRs keep the reasoning behind each choice available to people and agents.</a:t>
             </a:r>
             <a:endParaRPr lang="en-US" sz="1500" dirty="0"/>
           </a:p>
@@ -4700,7 +4700,7 @@
                   <a:schemeClr val="tx1"/>
                 </a:solidFill>
               </a:rPr>
-              <a:t>Four repositories, 24 ADRs, CI and Terraform</a:t>
+              <a:t>Four repositories, 23 ADRs, CI and Terraform</a:t>
             </a:r>
             <a:endParaRPr lang="en-US" sz="1500"/>
           </a:p>
@@ -5244,7 +5244,7 @@
       </p:sp>
       <p:pic>
         <p:nvPicPr>
-          <p:cNvPr id="14" name="Image 0" descr="/private/tmp/claude-501/-Users-alonso-Documents-Workspace-Alonsovndev-OpenProjectsHub/19cdd931-d4c3-4bf1-911a-d568f533b6da/scratchpad/deck/app-logo.png">    </p:cNvPr>
+          <p:cNvPr id="14" name="Image 0" descr="Open Projects Hub logo">    </p:cNvPr>
           <p:cNvPicPr>
             <a:picLocks noChangeAspect="1"/>
           </p:cNvPicPr>
@@ -7345,7 +7345,7 @@
       </p:sp>
       <p:pic>
         <p:nvPicPr>
-          <p:cNvPr id="4" name="Image 0" descr="/Users/alonso/Documents/Workspace/Alonsovndev/OpenProjectsHub/open-projects-hub-docs/static/img/product/refinement-workspace.png">    </p:cNvPr>
+          <p:cNvPr id="4" name="Image 0" descr="Refinement workspace screenshot (illustrative UI, fictional data)">    </p:cNvPr>
           <p:cNvPicPr>
             <a:picLocks noChangeAspect="1"/>
           </p:cNvPicPr>
@@ -7985,7 +7985,7 @@
       </p:sp>
       <p:pic>
         <p:nvPicPr>
-          <p:cNvPr id="4" name="Image 0" descr="/Users/alonso/Documents/Workspace/Alonsovndev/OpenProjectsHub/open-projects-hub-docs/static/img/product/approved-backlog.png">    </p:cNvPr>
+          <p:cNvPr id="4" name="Image 0" descr="Approved backlog screenshot (illustrative UI, fictional data)">    </p:cNvPr>
           <p:cNvPicPr>
             <a:picLocks noChangeAspect="1"/>
           </p:cNvPicPr>
@@ -8625,7 +8625,7 @@
       </p:sp>
       <p:pic>
         <p:nvPicPr>
-          <p:cNvPr id="4" name="Image 0" descr="/Users/alonso/Documents/Workspace/Alonsovndev/OpenProjectsHub/open-projects-hub-docs/static/img/product/client-review.png">    </p:cNvPr>
+          <p:cNvPr id="4" name="Image 0" descr="Client Review screenshot (illustrative UI, fictional data)">    </p:cNvPr>
           <p:cNvPicPr>
             <a:picLocks noChangeAspect="1"/>
           </p:cNvPicPr>
@@ -12415,7 +12415,7 @@
                   <a:schemeClr val="accent6"/>
                 </a:solidFill>
               </a:rPr>
-              <a:t>Free platform credits per workspace, or a personal API key encrypted at rest (ADR-018).</a:t>
+              <a:t>5 free credits per user, or a personal API key encrypted at rest (ADR-018).</a:t>
             </a:r>
             <a:endParaRPr lang="en-US" sz="1500" dirty="0"/>
           </a:p>

</xml_diff>